<commit_message>
documentation on extracting details and markers from pptx files
</commit_message>
<xml_diff>
--- a/reference-materials/original-templates/Powerpoint Slide Template D-Mission.pptx
+++ b/reference-materials/original-templates/Powerpoint Slide Template D-Mission.pptx
@@ -600,6 +600,7 @@
     </c:legend>
     <c:plotVisOnly val="1"/>
     <c:dispBlanksAs val="gap"/>
+    <c:showDLblsOverMax val="0"/>
     <c:extLst>
       <c:ext xmlns:c16r3="http://schemas.microsoft.com/office/drawing/2017/03/chart" uri="{56B9EC1D-385E-4148-901F-78D8002777C0}">
         <c16r3:dataDisplayOptions16>
@@ -607,7 +608,6 @@
         </c16r3:dataDisplayOptions16>
       </c:ext>
     </c:extLst>
-    <c:showDLblsOverMax val="0"/>
   </c:chart>
   <c:spPr>
     <a:noFill/>
@@ -895,6 +895,7 @@
     </c:legend>
     <c:plotVisOnly val="1"/>
     <c:dispBlanksAs val="gap"/>
+    <c:showDLblsOverMax val="0"/>
     <c:extLst>
       <c:ext xmlns:c16r3="http://schemas.microsoft.com/office/drawing/2017/03/chart" uri="{56B9EC1D-385E-4148-901F-78D8002777C0}">
         <c16r3:dataDisplayOptions16>
@@ -902,7 +903,6 @@
         </c16r3:dataDisplayOptions16>
       </c:ext>
     </c:extLst>
-    <c:showDLblsOverMax val="0"/>
   </c:chart>
   <c:spPr>
     <a:noFill/>
@@ -10664,7 +10664,7 @@
           <a:p>
             <a:fld id="{7F612655-39F8-F347-982F-58746B965C3A}" type="datetimeFigureOut">
               <a:rPr lang="en-US" smtClean="0"/>
-              <a:t>11/8/23</a:t>
+              <a:t>6/17/26</a:t>
             </a:fld>
             <a:endParaRPr lang="en-US"/>
           </a:p>
@@ -19086,56 +19086,6 @@
             <a:r>
               <a:rPr lang="en-US" i="1" dirty="0"/>
               <a:t>Created: Jan 2023</a:t>
-            </a:r>
-          </a:p>
-        </p:txBody>
-      </p:sp>
-      <p:sp>
-        <p:nvSpPr>
-          <p:cNvPr id="4" name="TextBox 3">
-            <a:extLst>
-              <a:ext uri="{FF2B5EF4-FFF2-40B4-BE49-F238E27FC236}">
-                <a16:creationId xmlns:a16="http://schemas.microsoft.com/office/drawing/2014/main" id="{91E03176-9795-631A-0AB6-BCB5B177D9BA}"/>
-              </a:ext>
-            </a:extLst>
-          </p:cNvPr>
-          <p:cNvSpPr txBox="1"/>
-          <p:nvPr/>
-        </p:nvSpPr>
-        <p:spPr>
-          <a:xfrm>
-            <a:off x="5544152" y="407170"/>
-            <a:ext cx="3263213" cy="646331"/>
-          </a:xfrm>
-          <a:prstGeom prst="rect">
-            <a:avLst/>
-          </a:prstGeom>
-          <a:solidFill>
-            <a:schemeClr val="tx2"/>
-          </a:solidFill>
-        </p:spPr>
-        <p:txBody>
-          <a:bodyPr wrap="square" lIns="91440" tIns="45720" rIns="91440" bIns="45720" rtlCol="0">
-            <a:spAutoFit/>
-          </a:bodyPr>
-          <a:lstStyle/>
-          <a:p>
-            <a:pPr algn="r"/>
-            <a:r>
-              <a:rPr lang="en-US" sz="1200" b="1" i="1" dirty="0">
-                <a:solidFill>
-                  <a:schemeClr val="bg1"/>
-                </a:solidFill>
-              </a:rPr>
-              <a:t>NOTE: </a:t>
-            </a:r>
-            <a:r>
-              <a:rPr lang="en-US" sz="1200" i="1" dirty="0">
-                <a:solidFill>
-                  <a:schemeClr val="bg1"/>
-                </a:solidFill>
-              </a:rPr>
-              <a:t>This is a PowerPoint template file (.POTX). Please download a copy to your own computer to use with Microsoft PowerPoint. </a:t>
             </a:r>
           </a:p>
         </p:txBody>
@@ -23559,10 +23509,10 @@
             <p:nvPr/>
           </p:nvPicPr>
           <p:blipFill>
-            <a:blip r:embed="rId2">
+            <a:blip>
               <a:extLst>
                 <a:ext uri="{96DAC541-7B7A-43D3-8B79-37D633B846F1}">
-                  <asvg:svgBlip xmlns:asvg="http://schemas.microsoft.com/office/drawing/2016/SVG/main" r:embed="rId3"/>
+                  <asvg:svgBlip xmlns:asvg="http://schemas.microsoft.com/office/drawing/2016/SVG/main" r:embed="rId2"/>
                 </a:ext>
               </a:extLst>
             </a:blip>
@@ -23595,10 +23545,10 @@
             <p:nvPr/>
           </p:nvPicPr>
           <p:blipFill>
-            <a:blip r:embed="rId4">
+            <a:blip>
               <a:extLst>
                 <a:ext uri="{96DAC541-7B7A-43D3-8B79-37D633B846F1}">
-                  <asvg:svgBlip xmlns:asvg="http://schemas.microsoft.com/office/drawing/2016/SVG/main" r:embed="rId5"/>
+                  <asvg:svgBlip xmlns:asvg="http://schemas.microsoft.com/office/drawing/2016/SVG/main" r:embed="rId3"/>
                 </a:ext>
               </a:extLst>
             </a:blip>
@@ -23631,10 +23581,10 @@
             <p:nvPr/>
           </p:nvPicPr>
           <p:blipFill>
-            <a:blip r:embed="rId6">
+            <a:blip>
               <a:extLst>
                 <a:ext uri="{96DAC541-7B7A-43D3-8B79-37D633B846F1}">
-                  <asvg:svgBlip xmlns:asvg="http://schemas.microsoft.com/office/drawing/2016/SVG/main" r:embed="rId7"/>
+                  <asvg:svgBlip xmlns:asvg="http://schemas.microsoft.com/office/drawing/2016/SVG/main" r:embed="rId4"/>
                 </a:ext>
               </a:extLst>
             </a:blip>
@@ -23667,10 +23617,10 @@
             <p:nvPr/>
           </p:nvPicPr>
           <p:blipFill>
-            <a:blip r:embed="rId8">
+            <a:blip>
               <a:extLst>
                 <a:ext uri="{96DAC541-7B7A-43D3-8B79-37D633B846F1}">
-                  <asvg:svgBlip xmlns:asvg="http://schemas.microsoft.com/office/drawing/2016/SVG/main" r:embed="rId9"/>
+                  <asvg:svgBlip xmlns:asvg="http://schemas.microsoft.com/office/drawing/2016/SVG/main" r:embed="rId5"/>
                 </a:ext>
               </a:extLst>
             </a:blip>
@@ -23703,10 +23653,10 @@
             <p:nvPr/>
           </p:nvPicPr>
           <p:blipFill>
-            <a:blip r:embed="rId10">
+            <a:blip>
               <a:extLst>
                 <a:ext uri="{96DAC541-7B7A-43D3-8B79-37D633B846F1}">
-                  <asvg:svgBlip xmlns:asvg="http://schemas.microsoft.com/office/drawing/2016/SVG/main" r:embed="rId11"/>
+                  <asvg:svgBlip xmlns:asvg="http://schemas.microsoft.com/office/drawing/2016/SVG/main" r:embed="rId6"/>
                 </a:ext>
               </a:extLst>
             </a:blip>
@@ -23739,10 +23689,10 @@
             <p:nvPr/>
           </p:nvPicPr>
           <p:blipFill>
-            <a:blip r:embed="rId12">
+            <a:blip>
               <a:extLst>
                 <a:ext uri="{96DAC541-7B7A-43D3-8B79-37D633B846F1}">
-                  <asvg:svgBlip xmlns:asvg="http://schemas.microsoft.com/office/drawing/2016/SVG/main" r:embed="rId13"/>
+                  <asvg:svgBlip xmlns:asvg="http://schemas.microsoft.com/office/drawing/2016/SVG/main" r:embed="rId7"/>
                 </a:ext>
               </a:extLst>
             </a:blip>
@@ -23775,10 +23725,10 @@
             <p:nvPr/>
           </p:nvPicPr>
           <p:blipFill>
-            <a:blip r:embed="rId14">
+            <a:blip>
               <a:extLst>
                 <a:ext uri="{96DAC541-7B7A-43D3-8B79-37D633B846F1}">
-                  <asvg:svgBlip xmlns:asvg="http://schemas.microsoft.com/office/drawing/2016/SVG/main" r:embed="rId15"/>
+                  <asvg:svgBlip xmlns:asvg="http://schemas.microsoft.com/office/drawing/2016/SVG/main" r:embed="rId8"/>
                 </a:ext>
               </a:extLst>
             </a:blip>
@@ -23811,10 +23761,10 @@
             <p:nvPr/>
           </p:nvPicPr>
           <p:blipFill>
-            <a:blip r:embed="rId16">
+            <a:blip>
               <a:extLst>
                 <a:ext uri="{96DAC541-7B7A-43D3-8B79-37D633B846F1}">
-                  <asvg:svgBlip xmlns:asvg="http://schemas.microsoft.com/office/drawing/2016/SVG/main" r:embed="rId17"/>
+                  <asvg:svgBlip xmlns:asvg="http://schemas.microsoft.com/office/drawing/2016/SVG/main" r:embed="rId9"/>
                 </a:ext>
               </a:extLst>
             </a:blip>
@@ -23847,10 +23797,10 @@
             <p:nvPr/>
           </p:nvPicPr>
           <p:blipFill>
-            <a:blip r:embed="rId18">
+            <a:blip>
               <a:extLst>
                 <a:ext uri="{96DAC541-7B7A-43D3-8B79-37D633B846F1}">
-                  <asvg:svgBlip xmlns:asvg="http://schemas.microsoft.com/office/drawing/2016/SVG/main" r:embed="rId19"/>
+                  <asvg:svgBlip xmlns:asvg="http://schemas.microsoft.com/office/drawing/2016/SVG/main" r:embed="rId10"/>
                 </a:ext>
               </a:extLst>
             </a:blip>
@@ -23883,10 +23833,10 @@
             <p:nvPr/>
           </p:nvPicPr>
           <p:blipFill>
-            <a:blip r:embed="rId20">
+            <a:blip>
               <a:extLst>
                 <a:ext uri="{96DAC541-7B7A-43D3-8B79-37D633B846F1}">
-                  <asvg:svgBlip xmlns:asvg="http://schemas.microsoft.com/office/drawing/2016/SVG/main" r:embed="rId21"/>
+                  <asvg:svgBlip xmlns:asvg="http://schemas.microsoft.com/office/drawing/2016/SVG/main" r:embed="rId11"/>
                 </a:ext>
               </a:extLst>
             </a:blip>
@@ -23919,10 +23869,10 @@
             <p:nvPr/>
           </p:nvPicPr>
           <p:blipFill>
-            <a:blip r:embed="rId22">
+            <a:blip>
               <a:extLst>
                 <a:ext uri="{96DAC541-7B7A-43D3-8B79-37D633B846F1}">
-                  <asvg:svgBlip xmlns:asvg="http://schemas.microsoft.com/office/drawing/2016/SVG/main" r:embed="rId23"/>
+                  <asvg:svgBlip xmlns:asvg="http://schemas.microsoft.com/office/drawing/2016/SVG/main" r:embed="rId12"/>
                 </a:ext>
               </a:extLst>
             </a:blip>
@@ -23955,10 +23905,10 @@
             <p:nvPr/>
           </p:nvPicPr>
           <p:blipFill>
-            <a:blip r:embed="rId24">
+            <a:blip>
               <a:extLst>
                 <a:ext uri="{96DAC541-7B7A-43D3-8B79-37D633B846F1}">
-                  <asvg:svgBlip xmlns:asvg="http://schemas.microsoft.com/office/drawing/2016/SVG/main" r:embed="rId25"/>
+                  <asvg:svgBlip xmlns:asvg="http://schemas.microsoft.com/office/drawing/2016/SVG/main" r:embed="rId13"/>
                 </a:ext>
               </a:extLst>
             </a:blip>
@@ -23991,10 +23941,10 @@
             <p:nvPr/>
           </p:nvPicPr>
           <p:blipFill>
-            <a:blip r:embed="rId26">
+            <a:blip>
               <a:extLst>
                 <a:ext uri="{96DAC541-7B7A-43D3-8B79-37D633B846F1}">
-                  <asvg:svgBlip xmlns:asvg="http://schemas.microsoft.com/office/drawing/2016/SVG/main" r:embed="rId27"/>
+                  <asvg:svgBlip xmlns:asvg="http://schemas.microsoft.com/office/drawing/2016/SVG/main" r:embed="rId14"/>
                 </a:ext>
               </a:extLst>
             </a:blip>
@@ -24027,10 +23977,10 @@
             <p:nvPr/>
           </p:nvPicPr>
           <p:blipFill>
-            <a:blip r:embed="rId28">
+            <a:blip>
               <a:extLst>
                 <a:ext uri="{96DAC541-7B7A-43D3-8B79-37D633B846F1}">
-                  <asvg:svgBlip xmlns:asvg="http://schemas.microsoft.com/office/drawing/2016/SVG/main" r:embed="rId29"/>
+                  <asvg:svgBlip xmlns:asvg="http://schemas.microsoft.com/office/drawing/2016/SVG/main" r:embed="rId15"/>
                 </a:ext>
               </a:extLst>
             </a:blip>
@@ -24063,10 +24013,10 @@
             <p:nvPr/>
           </p:nvPicPr>
           <p:blipFill>
-            <a:blip r:embed="rId30">
+            <a:blip>
               <a:extLst>
                 <a:ext uri="{96DAC541-7B7A-43D3-8B79-37D633B846F1}">
-                  <asvg:svgBlip xmlns:asvg="http://schemas.microsoft.com/office/drawing/2016/SVG/main" r:embed="rId31"/>
+                  <asvg:svgBlip xmlns:asvg="http://schemas.microsoft.com/office/drawing/2016/SVG/main" r:embed="rId16"/>
                 </a:ext>
               </a:extLst>
             </a:blip>
@@ -24099,10 +24049,10 @@
             <p:nvPr/>
           </p:nvPicPr>
           <p:blipFill>
-            <a:blip r:embed="rId32">
+            <a:blip>
               <a:extLst>
                 <a:ext uri="{96DAC541-7B7A-43D3-8B79-37D633B846F1}">
-                  <asvg:svgBlip xmlns:asvg="http://schemas.microsoft.com/office/drawing/2016/SVG/main" r:embed="rId33"/>
+                  <asvg:svgBlip xmlns:asvg="http://schemas.microsoft.com/office/drawing/2016/SVG/main" r:embed="rId17"/>
                 </a:ext>
               </a:extLst>
             </a:blip>
@@ -24135,10 +24085,10 @@
             <p:nvPr/>
           </p:nvPicPr>
           <p:blipFill>
-            <a:blip r:embed="rId34">
+            <a:blip>
               <a:extLst>
                 <a:ext uri="{96DAC541-7B7A-43D3-8B79-37D633B846F1}">
-                  <asvg:svgBlip xmlns:asvg="http://schemas.microsoft.com/office/drawing/2016/SVG/main" r:embed="rId35"/>
+                  <asvg:svgBlip xmlns:asvg="http://schemas.microsoft.com/office/drawing/2016/SVG/main" r:embed="rId18"/>
                 </a:ext>
               </a:extLst>
             </a:blip>
@@ -24171,10 +24121,10 @@
             <p:nvPr/>
           </p:nvPicPr>
           <p:blipFill>
-            <a:blip r:embed="rId36">
+            <a:blip>
               <a:extLst>
                 <a:ext uri="{96DAC541-7B7A-43D3-8B79-37D633B846F1}">
-                  <asvg:svgBlip xmlns:asvg="http://schemas.microsoft.com/office/drawing/2016/SVG/main" r:embed="rId37"/>
+                  <asvg:svgBlip xmlns:asvg="http://schemas.microsoft.com/office/drawing/2016/SVG/main" r:embed="rId19"/>
                 </a:ext>
               </a:extLst>
             </a:blip>
@@ -24207,10 +24157,10 @@
             <p:nvPr/>
           </p:nvPicPr>
           <p:blipFill>
-            <a:blip r:embed="rId38">
+            <a:blip>
               <a:extLst>
                 <a:ext uri="{96DAC541-7B7A-43D3-8B79-37D633B846F1}">
-                  <asvg:svgBlip xmlns:asvg="http://schemas.microsoft.com/office/drawing/2016/SVG/main" r:embed="rId39"/>
+                  <asvg:svgBlip xmlns:asvg="http://schemas.microsoft.com/office/drawing/2016/SVG/main" r:embed="rId20"/>
                 </a:ext>
               </a:extLst>
             </a:blip>
@@ -24243,10 +24193,10 @@
             <p:nvPr/>
           </p:nvPicPr>
           <p:blipFill>
-            <a:blip r:embed="rId40">
+            <a:blip>
               <a:extLst>
                 <a:ext uri="{96DAC541-7B7A-43D3-8B79-37D633B846F1}">
-                  <asvg:svgBlip xmlns:asvg="http://schemas.microsoft.com/office/drawing/2016/SVG/main" r:embed="rId41"/>
+                  <asvg:svgBlip xmlns:asvg="http://schemas.microsoft.com/office/drawing/2016/SVG/main" r:embed="rId21"/>
                 </a:ext>
               </a:extLst>
             </a:blip>
@@ -24279,10 +24229,10 @@
             <p:nvPr/>
           </p:nvPicPr>
           <p:blipFill>
-            <a:blip r:embed="rId42">
+            <a:blip>
               <a:extLst>
                 <a:ext uri="{96DAC541-7B7A-43D3-8B79-37D633B846F1}">
-                  <asvg:svgBlip xmlns:asvg="http://schemas.microsoft.com/office/drawing/2016/SVG/main" r:embed="rId43"/>
+                  <asvg:svgBlip xmlns:asvg="http://schemas.microsoft.com/office/drawing/2016/SVG/main" r:embed="rId22"/>
                 </a:ext>
               </a:extLst>
             </a:blip>
@@ -24315,10 +24265,10 @@
             <p:nvPr/>
           </p:nvPicPr>
           <p:blipFill>
-            <a:blip r:embed="rId44">
+            <a:blip>
               <a:extLst>
                 <a:ext uri="{96DAC541-7B7A-43D3-8B79-37D633B846F1}">
-                  <asvg:svgBlip xmlns:asvg="http://schemas.microsoft.com/office/drawing/2016/SVG/main" r:embed="rId45"/>
+                  <asvg:svgBlip xmlns:asvg="http://schemas.microsoft.com/office/drawing/2016/SVG/main" r:embed="rId23"/>
                 </a:ext>
               </a:extLst>
             </a:blip>
@@ -24351,10 +24301,10 @@
             <p:nvPr/>
           </p:nvPicPr>
           <p:blipFill>
-            <a:blip r:embed="rId46">
+            <a:blip>
               <a:extLst>
                 <a:ext uri="{96DAC541-7B7A-43D3-8B79-37D633B846F1}">
-                  <asvg:svgBlip xmlns:asvg="http://schemas.microsoft.com/office/drawing/2016/SVG/main" r:embed="rId47"/>
+                  <asvg:svgBlip xmlns:asvg="http://schemas.microsoft.com/office/drawing/2016/SVG/main" r:embed="rId24"/>
                 </a:ext>
               </a:extLst>
             </a:blip>
@@ -24387,10 +24337,10 @@
             <p:nvPr/>
           </p:nvPicPr>
           <p:blipFill>
-            <a:blip r:embed="rId48">
+            <a:blip>
               <a:extLst>
                 <a:ext uri="{96DAC541-7B7A-43D3-8B79-37D633B846F1}">
-                  <asvg:svgBlip xmlns:asvg="http://schemas.microsoft.com/office/drawing/2016/SVG/main" r:embed="rId49"/>
+                  <asvg:svgBlip xmlns:asvg="http://schemas.microsoft.com/office/drawing/2016/SVG/main" r:embed="rId25"/>
                 </a:ext>
               </a:extLst>
             </a:blip>
@@ -24423,10 +24373,10 @@
             <p:nvPr/>
           </p:nvPicPr>
           <p:blipFill>
-            <a:blip r:embed="rId50">
+            <a:blip>
               <a:extLst>
                 <a:ext uri="{96DAC541-7B7A-43D3-8B79-37D633B846F1}">
-                  <asvg:svgBlip xmlns:asvg="http://schemas.microsoft.com/office/drawing/2016/SVG/main" r:embed="rId51"/>
+                  <asvg:svgBlip xmlns:asvg="http://schemas.microsoft.com/office/drawing/2016/SVG/main" r:embed="rId26"/>
                 </a:ext>
               </a:extLst>
             </a:blip>
@@ -24483,10 +24433,10 @@
             <p:nvPr/>
           </p:nvPicPr>
           <p:blipFill>
-            <a:blip r:embed="rId52">
+            <a:blip>
               <a:extLst>
                 <a:ext uri="{96DAC541-7B7A-43D3-8B79-37D633B846F1}">
-                  <asvg:svgBlip xmlns:asvg="http://schemas.microsoft.com/office/drawing/2016/SVG/main" r:embed="rId53"/>
+                  <asvg:svgBlip xmlns:asvg="http://schemas.microsoft.com/office/drawing/2016/SVG/main" r:embed="rId27"/>
                 </a:ext>
               </a:extLst>
             </a:blip>
@@ -24519,10 +24469,10 @@
             <p:nvPr/>
           </p:nvPicPr>
           <p:blipFill>
-            <a:blip r:embed="rId54">
+            <a:blip>
               <a:extLst>
                 <a:ext uri="{96DAC541-7B7A-43D3-8B79-37D633B846F1}">
-                  <asvg:svgBlip xmlns:asvg="http://schemas.microsoft.com/office/drawing/2016/SVG/main" r:embed="rId55"/>
+                  <asvg:svgBlip xmlns:asvg="http://schemas.microsoft.com/office/drawing/2016/SVG/main" r:embed="rId28"/>
                 </a:ext>
               </a:extLst>
             </a:blip>
@@ -24555,10 +24505,10 @@
             <p:nvPr/>
           </p:nvPicPr>
           <p:blipFill>
-            <a:blip r:embed="rId56">
+            <a:blip>
               <a:extLst>
                 <a:ext uri="{96DAC541-7B7A-43D3-8B79-37D633B846F1}">
-                  <asvg:svgBlip xmlns:asvg="http://schemas.microsoft.com/office/drawing/2016/SVG/main" r:embed="rId57"/>
+                  <asvg:svgBlip xmlns:asvg="http://schemas.microsoft.com/office/drawing/2016/SVG/main" r:embed="rId29"/>
                 </a:ext>
               </a:extLst>
             </a:blip>
@@ -24591,10 +24541,10 @@
             <p:nvPr/>
           </p:nvPicPr>
           <p:blipFill>
-            <a:blip r:embed="rId58">
+            <a:blip>
               <a:extLst>
                 <a:ext uri="{96DAC541-7B7A-43D3-8B79-37D633B846F1}">
-                  <asvg:svgBlip xmlns:asvg="http://schemas.microsoft.com/office/drawing/2016/SVG/main" r:embed="rId59"/>
+                  <asvg:svgBlip xmlns:asvg="http://schemas.microsoft.com/office/drawing/2016/SVG/main" r:embed="rId30"/>
                 </a:ext>
               </a:extLst>
             </a:blip>
@@ -24627,10 +24577,10 @@
             <p:nvPr/>
           </p:nvPicPr>
           <p:blipFill>
-            <a:blip r:embed="rId60">
+            <a:blip>
               <a:extLst>
                 <a:ext uri="{96DAC541-7B7A-43D3-8B79-37D633B846F1}">
-                  <asvg:svgBlip xmlns:asvg="http://schemas.microsoft.com/office/drawing/2016/SVG/main" r:embed="rId61"/>
+                  <asvg:svgBlip xmlns:asvg="http://schemas.microsoft.com/office/drawing/2016/SVG/main" r:embed="rId31"/>
                 </a:ext>
               </a:extLst>
             </a:blip>
@@ -24663,10 +24613,10 @@
             <p:nvPr/>
           </p:nvPicPr>
           <p:blipFill>
-            <a:blip r:embed="rId62">
+            <a:blip>
               <a:extLst>
                 <a:ext uri="{96DAC541-7B7A-43D3-8B79-37D633B846F1}">
-                  <asvg:svgBlip xmlns:asvg="http://schemas.microsoft.com/office/drawing/2016/SVG/main" r:embed="rId63"/>
+                  <asvg:svgBlip xmlns:asvg="http://schemas.microsoft.com/office/drawing/2016/SVG/main" r:embed="rId32"/>
                 </a:ext>
               </a:extLst>
             </a:blip>
@@ -24699,10 +24649,10 @@
             <p:nvPr/>
           </p:nvPicPr>
           <p:blipFill>
-            <a:blip r:embed="rId64">
+            <a:blip>
               <a:extLst>
                 <a:ext uri="{96DAC541-7B7A-43D3-8B79-37D633B846F1}">
-                  <asvg:svgBlip xmlns:asvg="http://schemas.microsoft.com/office/drawing/2016/SVG/main" r:embed="rId65"/>
+                  <asvg:svgBlip xmlns:asvg="http://schemas.microsoft.com/office/drawing/2016/SVG/main" r:embed="rId33"/>
                 </a:ext>
               </a:extLst>
             </a:blip>
@@ -24735,10 +24685,10 @@
             <p:nvPr/>
           </p:nvPicPr>
           <p:blipFill>
-            <a:blip r:embed="rId66">
+            <a:blip>
               <a:extLst>
                 <a:ext uri="{96DAC541-7B7A-43D3-8B79-37D633B846F1}">
-                  <asvg:svgBlip xmlns:asvg="http://schemas.microsoft.com/office/drawing/2016/SVG/main" r:embed="rId67"/>
+                  <asvg:svgBlip xmlns:asvg="http://schemas.microsoft.com/office/drawing/2016/SVG/main" r:embed="rId34"/>
                 </a:ext>
               </a:extLst>
             </a:blip>
@@ -24771,10 +24721,10 @@
             <p:nvPr/>
           </p:nvPicPr>
           <p:blipFill>
-            <a:blip r:embed="rId68">
+            <a:blip>
               <a:extLst>
                 <a:ext uri="{96DAC541-7B7A-43D3-8B79-37D633B846F1}">
-                  <asvg:svgBlip xmlns:asvg="http://schemas.microsoft.com/office/drawing/2016/SVG/main" r:embed="rId69"/>
+                  <asvg:svgBlip xmlns:asvg="http://schemas.microsoft.com/office/drawing/2016/SVG/main" r:embed="rId35"/>
                 </a:ext>
               </a:extLst>
             </a:blip>
@@ -24807,10 +24757,10 @@
             <p:nvPr/>
           </p:nvPicPr>
           <p:blipFill>
-            <a:blip r:embed="rId70">
+            <a:blip>
               <a:extLst>
                 <a:ext uri="{96DAC541-7B7A-43D3-8B79-37D633B846F1}">
-                  <asvg:svgBlip xmlns:asvg="http://schemas.microsoft.com/office/drawing/2016/SVG/main" r:embed="rId71"/>
+                  <asvg:svgBlip xmlns:asvg="http://schemas.microsoft.com/office/drawing/2016/SVG/main" r:embed="rId36"/>
                 </a:ext>
               </a:extLst>
             </a:blip>
@@ -24843,10 +24793,10 @@
             <p:nvPr/>
           </p:nvPicPr>
           <p:blipFill>
-            <a:blip r:embed="rId72">
+            <a:blip>
               <a:extLst>
                 <a:ext uri="{96DAC541-7B7A-43D3-8B79-37D633B846F1}">
-                  <asvg:svgBlip xmlns:asvg="http://schemas.microsoft.com/office/drawing/2016/SVG/main" r:embed="rId73"/>
+                  <asvg:svgBlip xmlns:asvg="http://schemas.microsoft.com/office/drawing/2016/SVG/main" r:embed="rId37"/>
                 </a:ext>
               </a:extLst>
             </a:blip>
@@ -24879,10 +24829,10 @@
             <p:nvPr/>
           </p:nvPicPr>
           <p:blipFill>
-            <a:blip r:embed="rId74">
+            <a:blip>
               <a:extLst>
                 <a:ext uri="{96DAC541-7B7A-43D3-8B79-37D633B846F1}">
-                  <asvg:svgBlip xmlns:asvg="http://schemas.microsoft.com/office/drawing/2016/SVG/main" r:embed="rId75"/>
+                  <asvg:svgBlip xmlns:asvg="http://schemas.microsoft.com/office/drawing/2016/SVG/main" r:embed="rId38"/>
                 </a:ext>
               </a:extLst>
             </a:blip>
@@ -24915,10 +24865,10 @@
             <p:nvPr/>
           </p:nvPicPr>
           <p:blipFill>
-            <a:blip r:embed="rId76">
+            <a:blip>
               <a:extLst>
                 <a:ext uri="{96DAC541-7B7A-43D3-8B79-37D633B846F1}">
-                  <asvg:svgBlip xmlns:asvg="http://schemas.microsoft.com/office/drawing/2016/SVG/main" r:embed="rId77"/>
+                  <asvg:svgBlip xmlns:asvg="http://schemas.microsoft.com/office/drawing/2016/SVG/main" r:embed="rId39"/>
                 </a:ext>
               </a:extLst>
             </a:blip>
@@ -24951,10 +24901,10 @@
             <p:nvPr/>
           </p:nvPicPr>
           <p:blipFill>
-            <a:blip r:embed="rId78">
+            <a:blip>
               <a:extLst>
                 <a:ext uri="{96DAC541-7B7A-43D3-8B79-37D633B846F1}">
-                  <asvg:svgBlip xmlns:asvg="http://schemas.microsoft.com/office/drawing/2016/SVG/main" r:embed="rId79"/>
+                  <asvg:svgBlip xmlns:asvg="http://schemas.microsoft.com/office/drawing/2016/SVG/main" r:embed="rId40"/>
                 </a:ext>
               </a:extLst>
             </a:blip>
@@ -24987,10 +24937,10 @@
             <p:nvPr/>
           </p:nvPicPr>
           <p:blipFill>
-            <a:blip r:embed="rId80">
+            <a:blip>
               <a:extLst>
                 <a:ext uri="{96DAC541-7B7A-43D3-8B79-37D633B846F1}">
-                  <asvg:svgBlip xmlns:asvg="http://schemas.microsoft.com/office/drawing/2016/SVG/main" r:embed="rId81"/>
+                  <asvg:svgBlip xmlns:asvg="http://schemas.microsoft.com/office/drawing/2016/SVG/main" r:embed="rId41"/>
                 </a:ext>
               </a:extLst>
             </a:blip>
@@ -25023,10 +24973,10 @@
             <p:nvPr/>
           </p:nvPicPr>
           <p:blipFill>
-            <a:blip r:embed="rId82">
+            <a:blip>
               <a:extLst>
                 <a:ext uri="{96DAC541-7B7A-43D3-8B79-37D633B846F1}">
-                  <asvg:svgBlip xmlns:asvg="http://schemas.microsoft.com/office/drawing/2016/SVG/main" r:embed="rId83"/>
+                  <asvg:svgBlip xmlns:asvg="http://schemas.microsoft.com/office/drawing/2016/SVG/main" r:embed="rId42"/>
                 </a:ext>
               </a:extLst>
             </a:blip>
@@ -25059,10 +25009,10 @@
             <p:nvPr/>
           </p:nvPicPr>
           <p:blipFill>
-            <a:blip r:embed="rId84">
+            <a:blip>
               <a:extLst>
                 <a:ext uri="{96DAC541-7B7A-43D3-8B79-37D633B846F1}">
-                  <asvg:svgBlip xmlns:asvg="http://schemas.microsoft.com/office/drawing/2016/SVG/main" r:embed="rId85"/>
+                  <asvg:svgBlip xmlns:asvg="http://schemas.microsoft.com/office/drawing/2016/SVG/main" r:embed="rId43"/>
                 </a:ext>
               </a:extLst>
             </a:blip>
@@ -25095,10 +25045,10 @@
             <p:nvPr/>
           </p:nvPicPr>
           <p:blipFill>
-            <a:blip r:embed="rId86">
+            <a:blip>
               <a:extLst>
                 <a:ext uri="{96DAC541-7B7A-43D3-8B79-37D633B846F1}">
-                  <asvg:svgBlip xmlns:asvg="http://schemas.microsoft.com/office/drawing/2016/SVG/main" r:embed="rId87"/>
+                  <asvg:svgBlip xmlns:asvg="http://schemas.microsoft.com/office/drawing/2016/SVG/main" r:embed="rId44"/>
                 </a:ext>
               </a:extLst>
             </a:blip>
@@ -25131,10 +25081,10 @@
             <p:nvPr/>
           </p:nvPicPr>
           <p:blipFill>
-            <a:blip r:embed="rId88">
+            <a:blip>
               <a:extLst>
                 <a:ext uri="{96DAC541-7B7A-43D3-8B79-37D633B846F1}">
-                  <asvg:svgBlip xmlns:asvg="http://schemas.microsoft.com/office/drawing/2016/SVG/main" r:embed="rId89"/>
+                  <asvg:svgBlip xmlns:asvg="http://schemas.microsoft.com/office/drawing/2016/SVG/main" r:embed="rId45"/>
                 </a:ext>
               </a:extLst>
             </a:blip>
@@ -25167,10 +25117,10 @@
             <p:nvPr/>
           </p:nvPicPr>
           <p:blipFill>
-            <a:blip r:embed="rId90">
+            <a:blip>
               <a:extLst>
                 <a:ext uri="{96DAC541-7B7A-43D3-8B79-37D633B846F1}">
-                  <asvg:svgBlip xmlns:asvg="http://schemas.microsoft.com/office/drawing/2016/SVG/main" r:embed="rId91"/>
+                  <asvg:svgBlip xmlns:asvg="http://schemas.microsoft.com/office/drawing/2016/SVG/main" r:embed="rId46"/>
                 </a:ext>
               </a:extLst>
             </a:blip>
@@ -25203,10 +25153,10 @@
             <p:nvPr/>
           </p:nvPicPr>
           <p:blipFill>
-            <a:blip r:embed="rId92">
+            <a:blip>
               <a:extLst>
                 <a:ext uri="{96DAC541-7B7A-43D3-8B79-37D633B846F1}">
-                  <asvg:svgBlip xmlns:asvg="http://schemas.microsoft.com/office/drawing/2016/SVG/main" r:embed="rId93"/>
+                  <asvg:svgBlip xmlns:asvg="http://schemas.microsoft.com/office/drawing/2016/SVG/main" r:embed="rId47"/>
                 </a:ext>
               </a:extLst>
             </a:blip>
@@ -25239,10 +25189,10 @@
             <p:nvPr/>
           </p:nvPicPr>
           <p:blipFill>
-            <a:blip r:embed="rId94">
+            <a:blip>
               <a:extLst>
                 <a:ext uri="{96DAC541-7B7A-43D3-8B79-37D633B846F1}">
-                  <asvg:svgBlip xmlns:asvg="http://schemas.microsoft.com/office/drawing/2016/SVG/main" r:embed="rId95"/>
+                  <asvg:svgBlip xmlns:asvg="http://schemas.microsoft.com/office/drawing/2016/SVG/main" r:embed="rId48"/>
                 </a:ext>
               </a:extLst>
             </a:blip>
@@ -25275,10 +25225,10 @@
             <p:nvPr/>
           </p:nvPicPr>
           <p:blipFill>
-            <a:blip r:embed="rId96">
+            <a:blip>
               <a:extLst>
                 <a:ext uri="{96DAC541-7B7A-43D3-8B79-37D633B846F1}">
-                  <asvg:svgBlip xmlns:asvg="http://schemas.microsoft.com/office/drawing/2016/SVG/main" r:embed="rId97"/>
+                  <asvg:svgBlip xmlns:asvg="http://schemas.microsoft.com/office/drawing/2016/SVG/main" r:embed="rId49"/>
                 </a:ext>
               </a:extLst>
             </a:blip>
@@ -25311,10 +25261,10 @@
             <p:nvPr/>
           </p:nvPicPr>
           <p:blipFill>
-            <a:blip r:embed="rId98">
+            <a:blip>
               <a:extLst>
                 <a:ext uri="{96DAC541-7B7A-43D3-8B79-37D633B846F1}">
-                  <asvg:svgBlip xmlns:asvg="http://schemas.microsoft.com/office/drawing/2016/SVG/main" r:embed="rId99"/>
+                  <asvg:svgBlip xmlns:asvg="http://schemas.microsoft.com/office/drawing/2016/SVG/main" r:embed="rId50"/>
                 </a:ext>
               </a:extLst>
             </a:blip>
@@ -25347,10 +25297,10 @@
             <p:nvPr/>
           </p:nvPicPr>
           <p:blipFill>
-            <a:blip r:embed="rId100">
+            <a:blip>
               <a:extLst>
                 <a:ext uri="{96DAC541-7B7A-43D3-8B79-37D633B846F1}">
-                  <asvg:svgBlip xmlns:asvg="http://schemas.microsoft.com/office/drawing/2016/SVG/main" r:embed="rId101"/>
+                  <asvg:svgBlip xmlns:asvg="http://schemas.microsoft.com/office/drawing/2016/SVG/main" r:embed="rId51"/>
                 </a:ext>
               </a:extLst>
             </a:blip>
@@ -25410,7 +25360,7 @@
                 <a:solidFill>
                   <a:schemeClr val="bg1"/>
                 </a:solidFill>
-                <a:hlinkClick r:id="rId102">
+                <a:hlinkClick r:id="rId52">
                   <a:extLst>
                     <a:ext uri="{A12FA001-AC4F-418D-AE19-62706E023703}">
                       <ahyp:hlinkClr xmlns:ahyp="http://schemas.microsoft.com/office/drawing/2018/hyperlinkcolor" val="tx"/>

</xml_diff>